<commit_message>
Hapus ajakan tanya jawab di slide penutup presentasi
Co-Authored-By: Claude Opus 5.5 <noreply@anthropic.com>
</commit_message>
<xml_diff>
--- a/tugas2/Presentasi_Tugas2_Kelompok21.pptx
+++ b/tugas2/Presentasi_Tugas2_Kelompok21.pptx
@@ -114,25 +114,25 @@
   <p:extLst>
     <p:ext uri="{521415D9-36F7-43E2-AB2F-B90AF26B5E84}">
       <p14:sectionLst xmlns:p14="http://schemas.microsoft.com/office/powerpoint/2010/main">
-        <p14:section name="Pembuka" id="{eaeae7c0-0309-000f-684b-bce8bc0284c8}">
+        <p14:section name="Pembuka" id="{5f208a7e-7e82-8041-d0da-19a9c3c998fd}">
           <p14:sldIdLst>
             <p14:sldId id="256"/>
           </p14:sldIdLst>
         </p14:section>
-        <p14:section name="Eksperimen" id="{043632c6-0f71-1ce4-406e-0cd4937b731a}">
+        <p14:section name="Eksperimen" id="{c304436d-febe-7ee8-7766-7eb5b2c15221}">
           <p14:sldIdLst>
             <p14:sldId id="257"/>
             <p14:sldId id="258"/>
             <p14:sldId id="259"/>
           </p14:sldIdLst>
         </p14:section>
-        <p14:section name="Hasil" id="{ed45ac95-ddcd-ce56-cb1f-a81aaee08619}">
+        <p14:section name="Hasil" id="{71a39184-e668-070e-3d66-a1adaf2d3f8f}">
           <p14:sldIdLst>
             <p14:sldId id="260"/>
             <p14:sldId id="261"/>
           </p14:sldIdLst>
         </p14:section>
-        <p14:section name="Analisis" id="{145e68fc-29df-87a1-3ddd-b4d5d2599676}">
+        <p14:section name="Analisis" id="{a0e34181-b775-5dd0-9c09-e4cbbc190ef8}">
           <p14:sldIdLst>
             <p14:sldId id="262"/>
             <p14:sldId id="263"/>
@@ -2179,7 +2179,7 @@
           <a:p>
             <a:r>
               <a:rPr lang="en-US" dirty="0"/>
-              <a:t>[Riyan] Kesimpulannya: keempat cara memberi jawaban yang sama, dan Spark 2,2 sampai 4,1 kali lebih cepat, bahkan 5,9 kali dengan cache. Harganya, Spark butuh RAM sekitar dua kali dan waktu menyalakan 26 detik. Jadi pilihannya tergantung kebutuhan: DataFrame untuk data tabel, cache untuk data yang dipakai berulang, dan MapReduce kalau data sangat besar dan RAM terbatas. Terima kasih, kami siap menjawab pertanyaan.</a:t>
+              <a:t>[Riyan] Kesimpulannya: keempat cara memberi jawaban yang sama, dan Spark 2,2 sampai 4,1 kali lebih cepat, bahkan 5,9 kali dengan cache. Harganya, Spark butuh RAM sekitar dua kali dan waktu menyalakan 26 detik. Jadi pilihannya tergantung kebutuhan: DataFrame untuk data tabel, cache untuk data yang dipakai berulang, dan MapReduce kalau data sangat besar dan RAM terbatas. Terima kasih.</a:t>
             </a:r>
             <a:endParaRPr lang="en-US" dirty="0"/>
           </a:p>
@@ -8465,7 +8465,7 @@
                 <a:ea typeface="Cambria" pitchFamily="34" charset="-122"/>
                 <a:cs typeface="Cambria" pitchFamily="34" charset="-120"/>
               </a:rPr>
-              <a:t>Terima kasih · Ada pertanyaan?</a:t>
+              <a:t>Terima kasih</a:t>
             </a:r>
             <a:endParaRPr lang="en-US" sz="1800" dirty="0"/>
           </a:p>

</xml_diff>